<commit_message>
Refine Energy Transfer and Collision week
Co-authored-by: Cursor <cursoragent@cursor.com>
</commit_message>
<xml_diff>
--- a/production/releases/chapter-05/05-ch5-collisions-slides.pptx
+++ b/production/releases/chapter-05/05-ch5-collisions-slides.pptx
@@ -3224,7 +3224,7 @@
                 </a:solidFill>
                 <a:latin typeface="Arial"/>
               </a:rPr>
-              <a:t>Chapter 5 · Grade 4 · Week 6</a:t>
+              <a:t>Chapter 5 · Grade 4 · Week 3</a:t>
             </a:r>
           </a:p>
         </p:txBody>
@@ -5599,7 +5599,7 @@
                 </a:solidFill>
                 <a:latin typeface="Arial"/>
               </a:rPr>
-              <a:t>Notebook — model + fair test</a:t>
+              <a:t>Notes — model + fair test</a:t>
             </a:r>
           </a:p>
         </p:txBody>
@@ -5722,7 +5722,7 @@
                 </a:solidFill>
                 <a:latin typeface="Arial"/>
               </a:rPr>
-              <a:t>NOTEBOOK</a:t>
+              <a:t>NOTES</a:t>
             </a:r>
           </a:p>
         </p:txBody>
@@ -10003,7 +10003,7 @@
                 </a:solidFill>
                 <a:latin typeface="Arial"/>
               </a:rPr>
-              <a:t>Notebook — Part A + B evidence</a:t>
+              <a:t>Notes — Part A + B evidence</a:t>
             </a:r>
           </a:p>
         </p:txBody>
@@ -10126,7 +10126,7 @@
                 </a:solidFill>
                 <a:latin typeface="Arial"/>
               </a:rPr>
-              <a:t>NOTEBOOK</a:t>
+              <a:t>NOTES</a:t>
             </a:r>
           </a:p>
         </p:txBody>
@@ -11001,7 +11001,7 @@
                 </a:solidFill>
                 <a:latin typeface="Arial"/>
               </a:rPr>
-              <a:t>Notebook — lift the flap</a:t>
+              <a:t>Notes — lift the flap</a:t>
             </a:r>
           </a:p>
         </p:txBody>
@@ -11124,7 +11124,7 @@
                 </a:solidFill>
                 <a:latin typeface="Arial"/>
               </a:rPr>
-              <a:t>NOTEBOOK</a:t>
+              <a:t>NOTES</a:t>
             </a:r>
           </a:p>
         </p:txBody>
@@ -13710,7 +13710,7 @@
                 </a:solidFill>
                 <a:latin typeface="Arial"/>
               </a:rPr>
-              <a:t>Notebook — collision vocab</a:t>
+              <a:t>Notes — collision vocab</a:t>
             </a:r>
           </a:p>
         </p:txBody>
@@ -13833,7 +13833,7 @@
                 </a:solidFill>
                 <a:latin typeface="Arial"/>
               </a:rPr>
-              <a:t>NOTEBOOK</a:t>
+              <a:t>NOTES</a:t>
             </a:r>
           </a:p>
         </p:txBody>

</xml_diff>